<commit_message>
Add slide-specific images to CNC Plasma classroom PowerPoints
</commit_message>
<xml_diff>
--- a/CNC-Plasma/assets/downloads/module-01-classroom.pptx
+++ b/CNC-Plasma/assets/downloads/module-01-classroom.pptx
@@ -2,20 +2,20 @@
 <file path=ppt/presentation.xml><?xml version="1.0" encoding="utf-8"?>
 <p:presentation xmlns:p="http://schemas.openxmlformats.org/presentationml/2006/main">
   <p:sldMasterIdLst>
-    <p:sldMasterId xmlns:r="http://schemas.openxmlformats.org/officeDocument/2006/relationships" id="2147483648" r:id="Re1782501fdcb42a0"/>
+    <p:sldMasterId xmlns:r="http://schemas.openxmlformats.org/officeDocument/2006/relationships" id="2147483648" r:id="Rcc2b0ecb649144fd"/>
   </p:sldMasterIdLst>
   <p:notesMasterIdLst>
-    <p:notesMasterId xmlns:r="http://schemas.openxmlformats.org/officeDocument/2006/relationships" r:id="R2f856cf49564458f"/>
+    <p:notesMasterId xmlns:r="http://schemas.openxmlformats.org/officeDocument/2006/relationships" r:id="R794b939991004c28"/>
   </p:notesMasterIdLst>
   <p:sldIdLst>
-    <p:sldId xmlns:r="http://schemas.openxmlformats.org/officeDocument/2006/relationships" id="256" r:id="Ra982841fa7a84804"/>
-    <p:sldId xmlns:r="http://schemas.openxmlformats.org/officeDocument/2006/relationships" id="257" r:id="R6abcb5b92f0b4203"/>
-    <p:sldId xmlns:r="http://schemas.openxmlformats.org/officeDocument/2006/relationships" id="258" r:id="R3ecf222c56ce446f"/>
-    <p:sldId xmlns:r="http://schemas.openxmlformats.org/officeDocument/2006/relationships" id="259" r:id="R0f4e444c4f994156"/>
-    <p:sldId xmlns:r="http://schemas.openxmlformats.org/officeDocument/2006/relationships" id="260" r:id="Rebc7ecbea8f841b4"/>
-    <p:sldId xmlns:r="http://schemas.openxmlformats.org/officeDocument/2006/relationships" id="261" r:id="R734e00000cb440a1"/>
-    <p:sldId xmlns:r="http://schemas.openxmlformats.org/officeDocument/2006/relationships" id="262" r:id="R39d3788c7ec34d37"/>
-    <p:sldId xmlns:r="http://schemas.openxmlformats.org/officeDocument/2006/relationships" id="263" r:id="R328abdcee2e94695"/>
+    <p:sldId xmlns:r="http://schemas.openxmlformats.org/officeDocument/2006/relationships" id="256" r:id="R5b2714a0633b4086"/>
+    <p:sldId xmlns:r="http://schemas.openxmlformats.org/officeDocument/2006/relationships" id="257" r:id="Rf06dcbc0dcde41fd"/>
+    <p:sldId xmlns:r="http://schemas.openxmlformats.org/officeDocument/2006/relationships" id="258" r:id="R90b9d35d8fe141a2"/>
+    <p:sldId xmlns:r="http://schemas.openxmlformats.org/officeDocument/2006/relationships" id="259" r:id="Ra4d406e829314f47"/>
+    <p:sldId xmlns:r="http://schemas.openxmlformats.org/officeDocument/2006/relationships" id="260" r:id="Ra00424b0f0094739"/>
+    <p:sldId xmlns:r="http://schemas.openxmlformats.org/officeDocument/2006/relationships" id="261" r:id="Rde2f6d89d31544c4"/>
+    <p:sldId xmlns:r="http://schemas.openxmlformats.org/officeDocument/2006/relationships" id="262" r:id="R4a0c51e7b89d4d3d"/>
+    <p:sldId xmlns:r="http://schemas.openxmlformats.org/officeDocument/2006/relationships" id="263" r:id="R134e43dd7a5f45cf"/>
   </p:sldIdLst>
   <p:sldSz cx="12192000" cy="6858000"/>
   <p:notesSz cx="6858000" cy="9144000"/>
@@ -472,6 +472,26 @@
               <a:t>Source: XT12 Assembly Manual - ver 1.2.pdf</a:t>
             </a:r>
           </a:p>
+          <a:p xmlns:a="http://schemas.openxmlformats.org/drawingml/2006/main">
+            <a:r>
+              <a:t/>
+            </a:r>
+          </a:p>
+          <a:p xmlns:a="http://schemas.openxmlformats.org/drawingml/2006/main">
+            <a:r>
+              <a:t/>
+            </a:r>
+          </a:p>
+          <a:p xmlns:a="http://schemas.openxmlformats.org/drawingml/2006/main">
+            <a:r>
+              <a:t>ILLUSTRATIVE IMAGE</a:t>
+            </a:r>
+          </a:p>
+          <a:p xmlns:a="http://schemas.openxmlformats.org/drawingml/2006/main">
+            <a:r>
+              <a:t>AI-generated concept illustration for Meet the system. This illustration supports discussion and is not a photograph of the school installation, a software screenshot, or a machine-setting guide. Original source reference images remain on this slide where present.</a:t>
+            </a:r>
+          </a:p>
         </p:txBody>
       </p:sp>
       <p:sp>
@@ -557,6 +577,26 @@
               <a:t>m01-s03: Compare the two coordinate layouts for the proposed 100 mm square with a central Ø30 mm hole. Explain how you would establish that they represent the same geometry, and identify the information the trained teacher still needs before relating the drawing to a job on the table.</a:t>
             </a:r>
           </a:p>
+          <a:p xmlns:a="http://schemas.openxmlformats.org/drawingml/2006/main">
+            <a:r>
+              <a:t/>
+            </a:r>
+          </a:p>
+          <a:p xmlns:a="http://schemas.openxmlformats.org/drawingml/2006/main">
+            <a:r>
+              <a:t/>
+            </a:r>
+          </a:p>
+          <a:p xmlns:a="http://schemas.openxmlformats.org/drawingml/2006/main">
+            <a:r>
+              <a:t>ILLUSTRATIVE IMAGE</a:t>
+            </a:r>
+          </a:p>
+          <a:p xmlns:a="http://schemas.openxmlformats.org/drawingml/2006/main">
+            <a:r>
+              <a:t>AI-generated concept illustration for Today’s learning map. This illustration supports discussion and is not a photograph of the school installation, a software screenshot, or a machine-setting guide. Original source reference images remain on this slide where present.</a:t>
+            </a:r>
+          </a:p>
         </p:txBody>
       </p:sp>
       <p:sp>
@@ -727,6 +767,26 @@
               <a:t>Use the section’s ten questions for individual retrieval and feedback. Do not infer practical competence from online completion.</a:t>
             </a:r>
           </a:p>
+          <a:p xmlns:a="http://schemas.openxmlformats.org/drawingml/2006/main">
+            <a:r>
+              <a:t/>
+            </a:r>
+          </a:p>
+          <a:p xmlns:a="http://schemas.openxmlformats.org/drawingml/2006/main">
+            <a:r>
+              <a:t/>
+            </a:r>
+          </a:p>
+          <a:p xmlns:a="http://schemas.openxmlformats.org/drawingml/2006/main">
+            <a:r>
+              <a:t>ILLUSTRATIVE IMAGE</a:t>
+            </a:r>
+          </a:p>
+          <a:p xmlns:a="http://schemas.openxmlformats.org/drawingml/2006/main">
+            <a:r>
+              <a:t>AI-generated concept illustration for Three software jobs, one physical process. This illustration supports discussion and is not a photograph of the school installation, a software screenshot, or a machine-setting guide. Original source reference images remain on this slide where present.</a:t>
+            </a:r>
+          </a:p>
         </p:txBody>
       </p:sp>
       <p:sp>
@@ -897,6 +957,26 @@
               <a:t>Use the section’s ten questions for individual retrieval and feedback. Do not infer practical competence from online completion.</a:t>
             </a:r>
           </a:p>
+          <a:p xmlns:a="http://schemas.openxmlformats.org/drawingml/2006/main">
+            <a:r>
+              <a:t/>
+            </a:r>
+          </a:p>
+          <a:p xmlns:a="http://schemas.openxmlformats.org/drawingml/2006/main">
+            <a:r>
+              <a:t/>
+            </a:r>
+          </a:p>
+          <a:p xmlns:a="http://schemas.openxmlformats.org/drawingml/2006/main">
+            <a:r>
+              <a:t>ILLUSTRATIVE IMAGE</a:t>
+            </a:r>
+          </a:p>
+          <a:p xmlns:a="http://schemas.openxmlformats.org/drawingml/2006/main">
+            <a:r>
+              <a:t>AI-generated concept illustration for Know who does what. This illustration supports discussion and is not a photograph of the school installation, a software screenshot, or a machine-setting guide. Original source reference images remain on this slide where present.</a:t>
+            </a:r>
+          </a:p>
         </p:txBody>
       </p:sp>
       <p:sp>
@@ -1067,6 +1147,26 @@
               <a:t>Use the section’s ten questions for individual retrieval and feedback. Do not infer practical competence from online completion.</a:t>
             </a:r>
           </a:p>
+          <a:p xmlns:a="http://schemas.openxmlformats.org/drawingml/2006/main">
+            <a:r>
+              <a:t/>
+            </a:r>
+          </a:p>
+          <a:p xmlns:a="http://schemas.openxmlformats.org/drawingml/2006/main">
+            <a:r>
+              <a:t/>
+            </a:r>
+          </a:p>
+          <a:p xmlns:a="http://schemas.openxmlformats.org/drawingml/2006/main">
+            <a:r>
+              <a:t>ILLUSTRATIVE IMAGE</a:t>
+            </a:r>
+          </a:p>
+          <a:p xmlns:a="http://schemas.openxmlformats.org/drawingml/2006/main">
+            <a:r>
+              <a:t>AI-generated concept illustration for Read dimensions before coordinates. This illustration supports discussion and is not a photograph of the school installation, a software screenshot, or a machine-setting guide. Original source reference images remain on this slide where present.</a:t>
+            </a:r>
+          </a:p>
         </p:txBody>
       </p:sp>
       <p:sp>
@@ -1152,6 +1252,26 @@
               <a:t>Show where the centre lies, then explain diameter versus radius.</a:t>
             </a:r>
           </a:p>
+          <a:p xmlns:a="http://schemas.openxmlformats.org/drawingml/2006/main">
+            <a:r>
+              <a:t/>
+            </a:r>
+          </a:p>
+          <a:p xmlns:a="http://schemas.openxmlformats.org/drawingml/2006/main">
+            <a:r>
+              <a:t/>
+            </a:r>
+          </a:p>
+          <a:p xmlns:a="http://schemas.openxmlformats.org/drawingml/2006/main">
+            <a:r>
+              <a:t>ILLUSTRATIVE IMAGE</a:t>
+            </a:r>
+          </a:p>
+          <a:p xmlns:a="http://schemas.openxmlformats.org/drawingml/2006/main">
+            <a:r>
+              <a:t>AI-generated concept illustration for Pause before looking back. This illustration supports discussion and is not a photograph of the school installation, a software screenshot, or a machine-setting guide. Original source reference images remain on this slide where present.</a:t>
+            </a:r>
+          </a:p>
         </p:txBody>
       </p:sp>
       <p:sp>
@@ -1242,6 +1362,26 @@
               <a:t>Keeps physical positioning and machine controls within the teacher’s verified procedure.</a:t>
             </a:r>
           </a:p>
+          <a:p xmlns:a="http://schemas.openxmlformats.org/drawingml/2006/main">
+            <a:r>
+              <a:t/>
+            </a:r>
+          </a:p>
+          <a:p xmlns:a="http://schemas.openxmlformats.org/drawingml/2006/main">
+            <a:r>
+              <a:t/>
+            </a:r>
+          </a:p>
+          <a:p xmlns:a="http://schemas.openxmlformats.org/drawingml/2006/main">
+            <a:r>
+              <a:t>ILLUSTRATIVE IMAGE</a:t>
+            </a:r>
+          </a:p>
+          <a:p xmlns:a="http://schemas.openxmlformats.org/drawingml/2006/main">
+            <a:r>
+              <a:t>AI-generated concept illustration for Explain your decision with evidence. This illustration supports discussion and is not a photograph of the school installation, a software screenshot, or a machine-setting guide. Original source reference images remain on this slide where present.</a:t>
+            </a:r>
+          </a:p>
         </p:txBody>
       </p:sp>
       <p:sp>
@@ -1310,6 +1450,26 @@
           <a:p xmlns:a="http://schemas.openxmlformats.org/drawingml/2006/main">
             <a:r>
               <a:t>Open modules/module-01.html#module-01-review. Review completion and feedback rather than treating checked answers as a competence result. Keep original CAD files separately. Students should state their own contribution and identify teacher-controlled production honestly.</a:t>
+            </a:r>
+          </a:p>
+          <a:p xmlns:a="http://schemas.openxmlformats.org/drawingml/2006/main">
+            <a:r>
+              <a:t/>
+            </a:r>
+          </a:p>
+          <a:p xmlns:a="http://schemas.openxmlformats.org/drawingml/2006/main">
+            <a:r>
+              <a:t/>
+            </a:r>
+          </a:p>
+          <a:p xmlns:a="http://schemas.openxmlformats.org/drawingml/2006/main">
+            <a:r>
+              <a:t>ILLUSTRATIVE IMAGE</a:t>
+            </a:r>
+          </a:p>
+          <a:p xmlns:a="http://schemas.openxmlformats.org/drawingml/2006/main">
+            <a:r>
+              <a:t>AI-generated concept illustration for Leave with something useful. This illustration supports discussion and is not a photograph of the school installation, a software screenshot, or a machine-setting guide. Original source reference images remain on this slide where present.</a:t>
             </a:r>
           </a:p>
         </p:txBody>
@@ -1377,7 +1537,7 @@
   </p:cSld>
   <p:clrMap bg1="lt1" tx1="dk1" bg2="lt2" tx2="dk2" accent1="accent1" accent2="accent2" accent3="accent3" accent4="accent4" accent5="accent5" accent6="accent6" hlink="hlink" folHlink="folHlink"/>
   <p:sldLayoutIdLst>
-    <p:sldLayoutId xmlns:r="http://schemas.openxmlformats.org/officeDocument/2006/relationships" id="2147483649" r:id="R77456c6b36eb4d2a"/>
+    <p:sldLayoutId xmlns:r="http://schemas.openxmlformats.org/officeDocument/2006/relationships" id="2147483649" r:id="R9b65ac5f84c842c6"/>
   </p:sldLayoutIdLst>
   <p:txStyles>
     <p:titleStyle>
@@ -1987,6 +2147,7 @@
           <a:lstStyle xmlns:a="http://schemas.openxmlformats.org/drawingml/2006/main"/>
           <a:p xmlns:a="http://schemas.openxmlformats.org/drawingml/2006/main">
             <a:pPr>
+              <a:buNone/>
               <a:defRPr sz="1200" b="1">
                 <a:solidFill>
                   <a:srgbClr val="2F6079"/>
@@ -2044,6 +2205,7 @@
           <a:lstStyle xmlns:a="http://schemas.openxmlformats.org/drawingml/2006/main"/>
           <a:p xmlns:a="http://schemas.openxmlformats.org/drawingml/2006/main">
             <a:pPr>
+              <a:buNone/>
               <a:defRPr sz="1050" b="0">
                 <a:solidFill>
                   <a:srgbClr val="526571"/>
@@ -2101,6 +2263,7 @@
           <a:lstStyle xmlns:a="http://schemas.openxmlformats.org/drawingml/2006/main"/>
           <a:p xmlns:a="http://schemas.openxmlformats.org/drawingml/2006/main">
             <a:pPr>
+              <a:buNone/>
               <a:defRPr sz="1125" b="1">
                 <a:solidFill>
                   <a:srgbClr val="2F6079"/>
@@ -2158,6 +2321,7 @@
           <a:lstStyle xmlns:a="http://schemas.openxmlformats.org/drawingml/2006/main"/>
           <a:p xmlns:a="http://schemas.openxmlformats.org/drawingml/2006/main">
             <a:pPr>
+              <a:buNone/>
               <a:defRPr sz="3525" b="1">
                 <a:solidFill>
                   <a:srgbClr val="18303F"/>
@@ -2215,6 +2379,7 @@
           <a:lstStyle xmlns:a="http://schemas.openxmlformats.org/drawingml/2006/main"/>
           <a:p xmlns:a="http://schemas.openxmlformats.org/drawingml/2006/main">
             <a:pPr>
+              <a:buNone/>
               <a:defRPr sz="2025" b="0">
                 <a:solidFill>
                   <a:srgbClr val="18303F"/>
@@ -2272,6 +2437,7 @@
           <a:lstStyle xmlns:a="http://schemas.openxmlformats.org/drawingml/2006/main"/>
           <a:p xmlns:a="http://schemas.openxmlformats.org/drawingml/2006/main">
             <a:pPr>
+              <a:buNone/>
               <a:defRPr sz="1725" b="1">
                 <a:solidFill>
                   <a:srgbClr val="2F6079"/>
@@ -2312,7 +2478,7 @@
         <p:spPr>
           <a:xfrm xmlns:a="http://schemas.openxmlformats.org/drawingml/2006/main">
             <a:off x="6334125" y="1009650"/>
-            <a:ext cx="5314950" cy="4933950"/>
+            <a:ext cx="5314950" cy="4400550"/>
           </a:xfrm>
           <a:prstGeom xmlns:a="http://schemas.openxmlformats.org/drawingml/2006/main" prst="rect">
             <a:avLst/>
@@ -2327,20 +2493,20 @@
       </p:sp>
       <p:pic>
         <p:nvPicPr>
-          <p:cNvPr id="19" name=""/>
+          <p:cNvPr id="21" name=""/>
           <p:cNvPicPr>
             <a:picLocks xmlns:a="http://schemas.openxmlformats.org/drawingml/2006/main" noChangeAspect="1"/>
           </p:cNvPicPr>
           <p:nvPr/>
         </p:nvPicPr>
         <p:blipFill>
-          <a:blip xmlns:r="http://schemas.openxmlformats.org/officeDocument/2006/relationships" xmlns:a="http://schemas.openxmlformats.org/drawingml/2006/main" r:embed="R4cd3931b03e24b19"/>
+          <a:blip xmlns:r="http://schemas.openxmlformats.org/officeDocument/2006/relationships" xmlns:a="http://schemas.openxmlformats.org/drawingml/2006/main" r:embed="Rfd2aee4120114e35"/>
           <a:stretch xmlns:a="http://schemas.openxmlformats.org/drawingml/2006/main"/>
         </p:blipFill>
         <p:spPr>
           <a:xfrm xmlns:a="http://schemas.openxmlformats.org/drawingml/2006/main">
-            <a:off x="6524625" y="1352335"/>
-            <a:ext cx="4933950" cy="3486580"/>
+            <a:off x="6524625" y="1341438"/>
+            <a:ext cx="4933950" cy="3289300"/>
           </a:xfrm>
           <a:prstGeom xmlns:a="http://schemas.openxmlformats.org/drawingml/2006/main" prst="rect">
             <a:avLst/>
@@ -2363,8 +2529,8 @@
         </p:nvSpPr>
         <p:spPr>
           <a:xfrm xmlns:a="http://schemas.openxmlformats.org/drawingml/2006/main">
-            <a:off x="6543675" y="5238750"/>
-            <a:ext cx="4857750" cy="523875"/>
+            <a:off x="6524625" y="4895850"/>
+            <a:ext cx="4933950" cy="381000"/>
           </a:xfrm>
           <a:prstGeom xmlns:a="http://schemas.openxmlformats.org/drawingml/2006/main" prst="rect">
             <a:avLst/>
@@ -2381,9 +2547,10 @@
           <a:lstStyle xmlns:a="http://schemas.openxmlformats.org/drawingml/2006/main"/>
           <a:p xmlns:a="http://schemas.openxmlformats.org/drawingml/2006/main">
             <a:pPr>
+              <a:buNone/>
               <a:defRPr sz="1275" b="0">
                 <a:solidFill>
-                  <a:srgbClr val="526571"/>
+                  <a:srgbClr val="18303F"/>
                 </a:solidFill>
                 <a:latin typeface="Arial"/>
                 <a:ea typeface="Arial"/>
@@ -2393,13 +2560,13 @@
             <a:r>
               <a:rPr sz="1275" b="0">
                 <a:solidFill>
-                  <a:srgbClr val="526571"/>
-                </a:solidFill>
-                <a:latin typeface="Arial"/>
-                <a:ea typeface="Arial"/>
-                <a:cs typeface="Arial"/>
-              </a:rPr>
-              <a:t>Source reference / teaching example</a:t>
+                  <a:srgbClr val="18303F"/>
+                </a:solidFill>
+                <a:latin typeface="Arial"/>
+                <a:ea typeface="Arial"/>
+                <a:cs typeface="Arial"/>
+              </a:rPr>
+              <a:t>AI-generated concept image</a:t>
             </a:r>
           </a:p>
         </p:txBody>
@@ -2497,6 +2664,7 @@
           <a:lstStyle xmlns:a="http://schemas.openxmlformats.org/drawingml/2006/main"/>
           <a:p xmlns:a="http://schemas.openxmlformats.org/drawingml/2006/main">
             <a:pPr>
+              <a:buNone/>
               <a:defRPr sz="1200" b="1">
                 <a:solidFill>
                   <a:srgbClr val="2F6079"/>
@@ -2554,6 +2722,7 @@
           <a:lstStyle xmlns:a="http://schemas.openxmlformats.org/drawingml/2006/main"/>
           <a:p xmlns:a="http://schemas.openxmlformats.org/drawingml/2006/main">
             <a:pPr>
+              <a:buNone/>
               <a:defRPr sz="1050" b="0">
                 <a:solidFill>
                   <a:srgbClr val="526571"/>
@@ -2611,6 +2780,7 @@
           <a:lstStyle xmlns:a="http://schemas.openxmlformats.org/drawingml/2006/main"/>
           <a:p xmlns:a="http://schemas.openxmlformats.org/drawingml/2006/main">
             <a:pPr>
+              <a:buNone/>
               <a:defRPr sz="1125" b="1">
                 <a:solidFill>
                   <a:srgbClr val="2F6079"/>
@@ -2668,6 +2838,7 @@
           <a:lstStyle xmlns:a="http://schemas.openxmlformats.org/drawingml/2006/main"/>
           <a:p xmlns:a="http://schemas.openxmlformats.org/drawingml/2006/main">
             <a:pPr>
+              <a:buNone/>
               <a:defRPr sz="3225" b="1">
                 <a:solidFill>
                   <a:srgbClr val="18303F"/>
@@ -2725,6 +2896,7 @@
           <a:lstStyle xmlns:a="http://schemas.openxmlformats.org/drawingml/2006/main"/>
           <a:p xmlns:a="http://schemas.openxmlformats.org/drawingml/2006/main">
             <a:pPr>
+              <a:buNone/>
               <a:defRPr sz="3450" b="1">
                 <a:solidFill>
                   <a:srgbClr val="2F6079"/>
@@ -2765,7 +2937,7 @@
         <p:spPr>
           <a:xfrm xmlns:a="http://schemas.openxmlformats.org/drawingml/2006/main">
             <a:off x="1562100" y="2143125"/>
-            <a:ext cx="9620250" cy="742950"/>
+            <a:ext cx="6096000" cy="952500"/>
           </a:xfrm>
           <a:prstGeom xmlns:a="http://schemas.openxmlformats.org/drawingml/2006/main" prst="rect">
             <a:avLst/>
@@ -2782,7 +2954,8 @@
           <a:lstStyle xmlns:a="http://schemas.openxmlformats.org/drawingml/2006/main"/>
           <a:p xmlns:a="http://schemas.openxmlformats.org/drawingml/2006/main">
             <a:pPr>
-              <a:defRPr sz="2175" b="1">
+              <a:buNone/>
+              <a:defRPr sz="2100" b="1">
                 <a:solidFill>
                   <a:srgbClr val="18303F"/>
                 </a:solidFill>
@@ -2792,7 +2965,7 @@
               </a:defRPr>
             </a:pPr>
             <a:r>
-              <a:rPr sz="2175" b="1">
+              <a:rPr sz="2100" b="1">
                 <a:solidFill>
                   <a:srgbClr val="18303F"/>
                 </a:solidFill>
@@ -2839,6 +3012,7 @@
           <a:lstStyle xmlns:a="http://schemas.openxmlformats.org/drawingml/2006/main"/>
           <a:p xmlns:a="http://schemas.openxmlformats.org/drawingml/2006/main">
             <a:pPr>
+              <a:buNone/>
               <a:defRPr sz="3450" b="1">
                 <a:solidFill>
                   <a:srgbClr val="2F6079"/>
@@ -2879,7 +3053,7 @@
         <p:spPr>
           <a:xfrm xmlns:a="http://schemas.openxmlformats.org/drawingml/2006/main">
             <a:off x="1562100" y="3286125"/>
-            <a:ext cx="9620250" cy="742950"/>
+            <a:ext cx="6096000" cy="952500"/>
           </a:xfrm>
           <a:prstGeom xmlns:a="http://schemas.openxmlformats.org/drawingml/2006/main" prst="rect">
             <a:avLst/>
@@ -2896,7 +3070,8 @@
           <a:lstStyle xmlns:a="http://schemas.openxmlformats.org/drawingml/2006/main"/>
           <a:p xmlns:a="http://schemas.openxmlformats.org/drawingml/2006/main">
             <a:pPr>
-              <a:defRPr sz="2175" b="1">
+              <a:buNone/>
+              <a:defRPr sz="2100" b="1">
                 <a:solidFill>
                   <a:srgbClr val="18303F"/>
                 </a:solidFill>
@@ -2906,7 +3081,7 @@
               </a:defRPr>
             </a:pPr>
             <a:r>
-              <a:rPr sz="2175" b="1">
+              <a:rPr sz="2100" b="1">
                 <a:solidFill>
                   <a:srgbClr val="18303F"/>
                 </a:solidFill>
@@ -2953,6 +3128,7 @@
           <a:lstStyle xmlns:a="http://schemas.openxmlformats.org/drawingml/2006/main"/>
           <a:p xmlns:a="http://schemas.openxmlformats.org/drawingml/2006/main">
             <a:pPr>
+              <a:buNone/>
               <a:defRPr sz="3450" b="1">
                 <a:solidFill>
                   <a:srgbClr val="2F6079"/>
@@ -2993,7 +3169,7 @@
         <p:spPr>
           <a:xfrm xmlns:a="http://schemas.openxmlformats.org/drawingml/2006/main">
             <a:off x="1562100" y="4429125"/>
-            <a:ext cx="9620250" cy="742950"/>
+            <a:ext cx="6096000" cy="952500"/>
           </a:xfrm>
           <a:prstGeom xmlns:a="http://schemas.openxmlformats.org/drawingml/2006/main" prst="rect">
             <a:avLst/>
@@ -3010,7 +3186,8 @@
           <a:lstStyle xmlns:a="http://schemas.openxmlformats.org/drawingml/2006/main"/>
           <a:p xmlns:a="http://schemas.openxmlformats.org/drawingml/2006/main">
             <a:pPr>
-              <a:defRPr sz="2175" b="1">
+              <a:buNone/>
+              <a:defRPr sz="2100" b="1">
                 <a:solidFill>
                   <a:srgbClr val="18303F"/>
                 </a:solidFill>
@@ -3020,7 +3197,7 @@
               </a:defRPr>
             </a:pPr>
             <a:r>
-              <a:rPr sz="2175" b="1">
+              <a:rPr sz="2100" b="1">
                 <a:solidFill>
                   <a:srgbClr val="18303F"/>
                 </a:solidFill>
@@ -3067,6 +3244,7 @@
           <a:lstStyle xmlns:a="http://schemas.openxmlformats.org/drawingml/2006/main"/>
           <a:p xmlns:a="http://schemas.openxmlformats.org/drawingml/2006/main">
             <a:pPr>
+              <a:buNone/>
               <a:defRPr sz="1725" b="0">
                 <a:solidFill>
                   <a:srgbClr val="2F6079"/>
@@ -3086,6 +3264,85 @@
                 <a:cs typeface="Arial"/>
               </a:rPr>
               <a:t>Before we begin: which step in the workflow needs the strongest check?</a:t>
+            </a:r>
+          </a:p>
+        </p:txBody>
+      </p:sp>
+      <p:pic>
+        <p:nvPicPr>
+          <p:cNvPr id="28" name=""/>
+          <p:cNvPicPr>
+            <a:picLocks xmlns:a="http://schemas.openxmlformats.org/drawingml/2006/main" noChangeAspect="1"/>
+          </p:cNvPicPr>
+          <p:nvPr/>
+        </p:nvPicPr>
+        <p:blipFill>
+          <a:blip xmlns:r="http://schemas.openxmlformats.org/officeDocument/2006/relationships" xmlns:a="http://schemas.openxmlformats.org/drawingml/2006/main" r:embed="R02b1101ba1bd4b33"/>
+          <a:stretch xmlns:a="http://schemas.openxmlformats.org/drawingml/2006/main"/>
+        </p:blipFill>
+        <p:spPr>
+          <a:xfrm xmlns:a="http://schemas.openxmlformats.org/drawingml/2006/main">
+            <a:off x="7858125" y="2444750"/>
+            <a:ext cx="3810000" cy="2540000"/>
+          </a:xfrm>
+          <a:prstGeom xmlns:a="http://schemas.openxmlformats.org/drawingml/2006/main" prst="rect">
+            <a:avLst/>
+          </a:prstGeom>
+        </p:spPr>
+      </p:pic>
+      <p:sp>
+        <p:nvSpPr>
+          <p:cNvPr id="15" name="">
+            <a:extLst xmlns:a="http://schemas.openxmlformats.org/drawingml/2006/main">
+              <a:ext uri="{FF2B5EF4-FFF2-40B4-BE49-F238E27FC236}">
+                <a16:creationId xmlns:a16="http://schemas.microsoft.com/office/drawing/2014/main" id="{351B6010-9319-450B-9548-54B6F389A517}"/>
+              </a:ext>
+            </a:extLst>
+          </p:cNvPr>
+          <p:cNvSpPr>
+            <a:spLocks xmlns:a="http://schemas.openxmlformats.org/drawingml/2006/main" noGrp="1"/>
+          </p:cNvSpPr>
+          <p:nvPr/>
+        </p:nvSpPr>
+        <p:spPr>
+          <a:xfrm xmlns:a="http://schemas.openxmlformats.org/drawingml/2006/main">
+            <a:off x="7858125" y="5562600"/>
+            <a:ext cx="3810000" cy="171450"/>
+          </a:xfrm>
+          <a:prstGeom xmlns:a="http://schemas.openxmlformats.org/drawingml/2006/main" prst="rect">
+            <a:avLst/>
+          </a:prstGeom>
+          <a:noFill xmlns:a="http://schemas.openxmlformats.org/drawingml/2006/main"/>
+          <a:ln xmlns:a="http://schemas.openxmlformats.org/drawingml/2006/main" w="0">
+            <a:noFill/>
+          </a:ln>
+        </p:spPr>
+        <p:txBody>
+          <a:bodyPr xmlns:a="http://schemas.openxmlformats.org/drawingml/2006/main">
+            <a:noAutofit/>
+          </a:bodyPr>
+          <a:lstStyle xmlns:a="http://schemas.openxmlformats.org/drawingml/2006/main"/>
+          <a:p xmlns:a="http://schemas.openxmlformats.org/drawingml/2006/main">
+            <a:pPr>
+              <a:defRPr sz="900">
+                <a:solidFill>
+                  <a:srgbClr val="526571"/>
+                </a:solidFill>
+                <a:latin typeface="Arial"/>
+                <a:ea typeface="Arial"/>
+                <a:cs typeface="Arial"/>
+              </a:defRPr>
+            </a:pPr>
+            <a:r>
+              <a:rPr sz="900">
+                <a:solidFill>
+                  <a:srgbClr val="526571"/>
+                </a:solidFill>
+                <a:latin typeface="Arial"/>
+                <a:ea typeface="Arial"/>
+                <a:cs typeface="Arial"/>
+              </a:rPr>
+              <a:t>AI-generated concept image</a:t>
             </a:r>
           </a:p>
         </p:txBody>
@@ -3183,6 +3440,7 @@
           <a:lstStyle xmlns:a="http://schemas.openxmlformats.org/drawingml/2006/main"/>
           <a:p xmlns:a="http://schemas.openxmlformats.org/drawingml/2006/main">
             <a:pPr>
+              <a:buNone/>
               <a:defRPr sz="1200" b="1">
                 <a:solidFill>
                   <a:srgbClr val="2F6079"/>
@@ -3240,6 +3498,7 @@
           <a:lstStyle xmlns:a="http://schemas.openxmlformats.org/drawingml/2006/main"/>
           <a:p xmlns:a="http://schemas.openxmlformats.org/drawingml/2006/main">
             <a:pPr>
+              <a:buNone/>
               <a:defRPr sz="1050" b="0">
                 <a:solidFill>
                   <a:srgbClr val="526571"/>
@@ -3297,6 +3556,7 @@
           <a:lstStyle xmlns:a="http://schemas.openxmlformats.org/drawingml/2006/main"/>
           <a:p xmlns:a="http://schemas.openxmlformats.org/drawingml/2006/main">
             <a:pPr>
+              <a:buNone/>
               <a:defRPr sz="1125" b="1">
                 <a:solidFill>
                   <a:srgbClr val="2F6079"/>
@@ -3354,6 +3614,7 @@
           <a:lstStyle xmlns:a="http://schemas.openxmlformats.org/drawingml/2006/main"/>
           <a:p xmlns:a="http://schemas.openxmlformats.org/drawingml/2006/main">
             <a:pPr>
+              <a:buNone/>
               <a:defRPr sz="2850" b="1">
                 <a:solidFill>
                   <a:srgbClr val="18303F"/>
@@ -3411,6 +3672,7 @@
           <a:lstStyle xmlns:a="http://schemas.openxmlformats.org/drawingml/2006/main"/>
           <a:p xmlns:a="http://schemas.openxmlformats.org/drawingml/2006/main">
             <a:pPr>
+              <a:buNone/>
               <a:defRPr sz="1875" b="0">
                 <a:solidFill>
                   <a:srgbClr val="18303F"/>
@@ -3439,6 +3701,7 @@
           </a:p>
           <a:p xmlns:a="http://schemas.openxmlformats.org/drawingml/2006/main">
             <a:pPr>
+              <a:buNone/>
               <a:defRPr sz="1875" b="0">
                 <a:solidFill>
                   <a:srgbClr val="18303F"/>
@@ -3478,8 +3741,8 @@
         </p:nvSpPr>
         <p:spPr>
           <a:xfrm xmlns:a="http://schemas.openxmlformats.org/drawingml/2006/main">
-            <a:off x="5810250" y="1962150"/>
-            <a:ext cx="5857875" cy="3238500"/>
+            <a:off x="5810250" y="1714500"/>
+            <a:ext cx="5857875" cy="2876550"/>
           </a:xfrm>
           <a:prstGeom xmlns:a="http://schemas.openxmlformats.org/drawingml/2006/main" prst="rect">
             <a:avLst/>
@@ -3494,20 +3757,21 @@
       </p:sp>
       <p:pic>
         <p:nvPicPr>
-          <p:cNvPr id="18" name=""/>
+          <p:cNvPr id="22" name=""/>
           <p:cNvPicPr>
             <a:picLocks xmlns:a="http://schemas.openxmlformats.org/drawingml/2006/main" noChangeAspect="1"/>
           </p:cNvPicPr>
           <p:nvPr/>
         </p:nvPicPr>
         <p:blipFill>
-          <a:blip xmlns:r="http://schemas.openxmlformats.org/officeDocument/2006/relationships" xmlns:a="http://schemas.openxmlformats.org/drawingml/2006/main" r:embed="R8294660c7edc4e66"/>
+          <a:blip xmlns:r="http://schemas.openxmlformats.org/officeDocument/2006/relationships" xmlns:a="http://schemas.openxmlformats.org/drawingml/2006/main" r:embed="R829b6ddafc864007"/>
+          <a:srcRect xmlns:a="http://schemas.openxmlformats.org/drawingml/2006/main" l="0" t="0" r="0" b="0"/>
           <a:stretch xmlns:a="http://schemas.openxmlformats.org/drawingml/2006/main"/>
         </p:blipFill>
         <p:spPr>
           <a:xfrm xmlns:a="http://schemas.openxmlformats.org/drawingml/2006/main">
-            <a:off x="6555577" y="2038350"/>
-            <a:ext cx="4367221" cy="3086100"/>
+            <a:off x="6811683" y="1790700"/>
+            <a:ext cx="3855009" cy="2724150"/>
           </a:xfrm>
           <a:prstGeom xmlns:a="http://schemas.openxmlformats.org/drawingml/2006/main" prst="rect">
             <a:avLst/>
@@ -3530,8 +3794,8 @@
         </p:nvSpPr>
         <p:spPr>
           <a:xfrm xmlns:a="http://schemas.openxmlformats.org/drawingml/2006/main">
-            <a:off x="5838825" y="5324475"/>
-            <a:ext cx="5810250" cy="600075"/>
+            <a:off x="8096250" y="4819650"/>
+            <a:ext cx="3571875" cy="1257300"/>
           </a:xfrm>
           <a:prstGeom xmlns:a="http://schemas.openxmlformats.org/drawingml/2006/main" prst="rect">
             <a:avLst/>
@@ -3548,9 +3812,10 @@
           <a:lstStyle xmlns:a="http://schemas.openxmlformats.org/drawingml/2006/main"/>
           <a:p xmlns:a="http://schemas.openxmlformats.org/drawingml/2006/main">
             <a:pPr>
+              <a:buNone/>
               <a:defRPr sz="1125" b="0">
                 <a:solidFill>
-                  <a:srgbClr val="526571"/>
+                  <a:srgbClr val="18303F"/>
                 </a:solidFill>
                 <a:latin typeface="Arial"/>
                 <a:ea typeface="Arial"/>
@@ -3560,7 +3825,7 @@
             <a:r>
               <a:rPr sz="1125" b="0">
                 <a:solidFill>
-                  <a:srgbClr val="526571"/>
+                  <a:srgbClr val="18303F"/>
                 </a:solidFill>
                 <a:latin typeface="Arial"/>
                 <a:ea typeface="Arial"/>
@@ -3605,6 +3870,7 @@
           <a:lstStyle xmlns:a="http://schemas.openxmlformats.org/drawingml/2006/main"/>
           <a:p xmlns:a="http://schemas.openxmlformats.org/drawingml/2006/main">
             <a:pPr>
+              <a:buNone/>
               <a:defRPr sz="1725" b="1">
                 <a:solidFill>
                   <a:srgbClr val="2F6079"/>
@@ -3624,6 +3890,85 @@
                 <a:cs typeface="Arial"/>
               </a:rPr>
               <a:t>Trace one design decision from CAD to the finished edge.</a:t>
+            </a:r>
+          </a:p>
+        </p:txBody>
+      </p:sp>
+      <p:pic>
+        <p:nvPicPr>
+          <p:cNvPr id="25" name=""/>
+          <p:cNvPicPr>
+            <a:picLocks xmlns:a="http://schemas.openxmlformats.org/drawingml/2006/main" noChangeAspect="1"/>
+          </p:cNvPicPr>
+          <p:nvPr/>
+        </p:nvPicPr>
+        <p:blipFill>
+          <a:blip xmlns:r="http://schemas.openxmlformats.org/officeDocument/2006/relationships" xmlns:a="http://schemas.openxmlformats.org/drawingml/2006/main" r:embed="R89e97cdd251642ca"/>
+          <a:stretch xmlns:a="http://schemas.openxmlformats.org/drawingml/2006/main"/>
+        </p:blipFill>
+        <p:spPr>
+          <a:xfrm xmlns:a="http://schemas.openxmlformats.org/drawingml/2006/main">
+            <a:off x="5826919" y="4762500"/>
+            <a:ext cx="2014538" cy="1343025"/>
+          </a:xfrm>
+          <a:prstGeom xmlns:a="http://schemas.openxmlformats.org/drawingml/2006/main" prst="rect">
+            <a:avLst/>
+          </a:prstGeom>
+        </p:spPr>
+      </p:pic>
+      <p:sp>
+        <p:nvSpPr>
+          <p:cNvPr id="14" name="">
+            <a:extLst xmlns:a="http://schemas.openxmlformats.org/drawingml/2006/main">
+              <a:ext uri="{FF2B5EF4-FFF2-40B4-BE49-F238E27FC236}">
+                <a16:creationId xmlns:a16="http://schemas.microsoft.com/office/drawing/2014/main" id="{FF2ACE21-6DA7-4339-A81E-BA0F0C99441E}"/>
+              </a:ext>
+            </a:extLst>
+          </p:cNvPr>
+          <p:cNvSpPr>
+            <a:spLocks xmlns:a="http://schemas.openxmlformats.org/drawingml/2006/main" noGrp="1"/>
+          </p:cNvSpPr>
+          <p:nvPr/>
+        </p:nvSpPr>
+        <p:spPr>
+          <a:xfrm xmlns:a="http://schemas.openxmlformats.org/drawingml/2006/main">
+            <a:off x="5810250" y="6115050"/>
+            <a:ext cx="2286000" cy="171450"/>
+          </a:xfrm>
+          <a:prstGeom xmlns:a="http://schemas.openxmlformats.org/drawingml/2006/main" prst="rect">
+            <a:avLst/>
+          </a:prstGeom>
+          <a:noFill xmlns:a="http://schemas.openxmlformats.org/drawingml/2006/main"/>
+          <a:ln xmlns:a="http://schemas.openxmlformats.org/drawingml/2006/main" w="0">
+            <a:noFill/>
+          </a:ln>
+        </p:spPr>
+        <p:txBody>
+          <a:bodyPr xmlns:a="http://schemas.openxmlformats.org/drawingml/2006/main">
+            <a:noAutofit/>
+          </a:bodyPr>
+          <a:lstStyle xmlns:a="http://schemas.openxmlformats.org/drawingml/2006/main"/>
+          <a:p xmlns:a="http://schemas.openxmlformats.org/drawingml/2006/main">
+            <a:pPr>
+              <a:defRPr sz="900">
+                <a:solidFill>
+                  <a:srgbClr val="526571"/>
+                </a:solidFill>
+                <a:latin typeface="Arial"/>
+                <a:ea typeface="Arial"/>
+                <a:cs typeface="Arial"/>
+              </a:defRPr>
+            </a:pPr>
+            <a:r>
+              <a:rPr sz="900">
+                <a:solidFill>
+                  <a:srgbClr val="526571"/>
+                </a:solidFill>
+                <a:latin typeface="Arial"/>
+                <a:ea typeface="Arial"/>
+                <a:cs typeface="Arial"/>
+              </a:rPr>
+              <a:t>AI-generated concept image</a:t>
             </a:r>
           </a:p>
         </p:txBody>
@@ -3721,6 +4066,7 @@
           <a:lstStyle xmlns:a="http://schemas.openxmlformats.org/drawingml/2006/main"/>
           <a:p xmlns:a="http://schemas.openxmlformats.org/drawingml/2006/main">
             <a:pPr>
+              <a:buNone/>
               <a:defRPr sz="1200" b="1">
                 <a:solidFill>
                   <a:srgbClr val="2F6079"/>
@@ -3778,6 +4124,7 @@
           <a:lstStyle xmlns:a="http://schemas.openxmlformats.org/drawingml/2006/main"/>
           <a:p xmlns:a="http://schemas.openxmlformats.org/drawingml/2006/main">
             <a:pPr>
+              <a:buNone/>
               <a:defRPr sz="1050" b="0">
                 <a:solidFill>
                   <a:srgbClr val="526571"/>
@@ -3835,6 +4182,7 @@
           <a:lstStyle xmlns:a="http://schemas.openxmlformats.org/drawingml/2006/main"/>
           <a:p xmlns:a="http://schemas.openxmlformats.org/drawingml/2006/main">
             <a:pPr>
+              <a:buNone/>
               <a:defRPr sz="1125" b="1">
                 <a:solidFill>
                   <a:srgbClr val="2F6079"/>
@@ -3892,6 +4240,7 @@
           <a:lstStyle xmlns:a="http://schemas.openxmlformats.org/drawingml/2006/main"/>
           <a:p xmlns:a="http://schemas.openxmlformats.org/drawingml/2006/main">
             <a:pPr>
+              <a:buNone/>
               <a:defRPr sz="2850" b="1">
                 <a:solidFill>
                   <a:srgbClr val="18303F"/>
@@ -3949,6 +4298,7 @@
           <a:lstStyle xmlns:a="http://schemas.openxmlformats.org/drawingml/2006/main"/>
           <a:p xmlns:a="http://schemas.openxmlformats.org/drawingml/2006/main">
             <a:pPr>
+              <a:buNone/>
               <a:defRPr sz="1875" b="0">
                 <a:solidFill>
                   <a:srgbClr val="18303F"/>
@@ -3977,6 +4327,7 @@
           </a:p>
           <a:p xmlns:a="http://schemas.openxmlformats.org/drawingml/2006/main">
             <a:pPr>
+              <a:buNone/>
               <a:defRPr sz="1875" b="0">
                 <a:solidFill>
                   <a:srgbClr val="18303F"/>
@@ -4016,8 +4367,8 @@
         </p:nvSpPr>
         <p:spPr>
           <a:xfrm xmlns:a="http://schemas.openxmlformats.org/drawingml/2006/main">
-            <a:off x="5810250" y="1962150"/>
-            <a:ext cx="5857875" cy="3238500"/>
+            <a:off x="5810250" y="1714500"/>
+            <a:ext cx="5857875" cy="2876550"/>
           </a:xfrm>
           <a:prstGeom xmlns:a="http://schemas.openxmlformats.org/drawingml/2006/main" prst="rect">
             <a:avLst/>
@@ -4032,20 +4383,21 @@
       </p:sp>
       <p:pic>
         <p:nvPicPr>
-          <p:cNvPr id="18" name=""/>
+          <p:cNvPr id="22" name=""/>
           <p:cNvPicPr>
             <a:picLocks xmlns:a="http://schemas.openxmlformats.org/drawingml/2006/main" noChangeAspect="1"/>
           </p:cNvPicPr>
           <p:nvPr/>
         </p:nvPicPr>
         <p:blipFill>
-          <a:blip xmlns:r="http://schemas.openxmlformats.org/officeDocument/2006/relationships" xmlns:a="http://schemas.openxmlformats.org/drawingml/2006/main" r:embed="Rdb5ee98423c54d10"/>
+          <a:blip xmlns:r="http://schemas.openxmlformats.org/officeDocument/2006/relationships" xmlns:a="http://schemas.openxmlformats.org/drawingml/2006/main" r:embed="R858d44ed341c4738"/>
+          <a:srcRect xmlns:a="http://schemas.openxmlformats.org/drawingml/2006/main" l="0" t="0" r="0" b="0"/>
           <a:stretch xmlns:a="http://schemas.openxmlformats.org/drawingml/2006/main"/>
         </p:blipFill>
         <p:spPr>
           <a:xfrm xmlns:a="http://schemas.openxmlformats.org/drawingml/2006/main">
-            <a:off x="6555577" y="2038350"/>
-            <a:ext cx="4367221" cy="3086100"/>
+            <a:off x="6811683" y="1790700"/>
+            <a:ext cx="3855009" cy="2724150"/>
           </a:xfrm>
           <a:prstGeom xmlns:a="http://schemas.openxmlformats.org/drawingml/2006/main" prst="rect">
             <a:avLst/>
@@ -4068,8 +4420,8 @@
         </p:nvSpPr>
         <p:spPr>
           <a:xfrm xmlns:a="http://schemas.openxmlformats.org/drawingml/2006/main">
-            <a:off x="5838825" y="5324475"/>
-            <a:ext cx="5810250" cy="600075"/>
+            <a:off x="8096250" y="4819650"/>
+            <a:ext cx="3571875" cy="1257300"/>
           </a:xfrm>
           <a:prstGeom xmlns:a="http://schemas.openxmlformats.org/drawingml/2006/main" prst="rect">
             <a:avLst/>
@@ -4086,9 +4438,10 @@
           <a:lstStyle xmlns:a="http://schemas.openxmlformats.org/drawingml/2006/main"/>
           <a:p xmlns:a="http://schemas.openxmlformats.org/drawingml/2006/main">
             <a:pPr>
+              <a:buNone/>
               <a:defRPr sz="1125" b="0">
                 <a:solidFill>
-                  <a:srgbClr val="526571"/>
+                  <a:srgbClr val="18303F"/>
                 </a:solidFill>
                 <a:latin typeface="Arial"/>
                 <a:ea typeface="Arial"/>
@@ -4098,7 +4451,7 @@
             <a:r>
               <a:rPr sz="1125" b="0">
                 <a:solidFill>
-                  <a:srgbClr val="526571"/>
+                  <a:srgbClr val="18303F"/>
                 </a:solidFill>
                 <a:latin typeface="Arial"/>
                 <a:ea typeface="Arial"/>
@@ -4143,6 +4496,7 @@
           <a:lstStyle xmlns:a="http://schemas.openxmlformats.org/drawingml/2006/main"/>
           <a:p xmlns:a="http://schemas.openxmlformats.org/drawingml/2006/main">
             <a:pPr>
+              <a:buNone/>
               <a:defRPr sz="1725" b="1">
                 <a:solidFill>
                   <a:srgbClr val="2F6079"/>
@@ -4162,6 +4516,85 @@
                 <a:cs typeface="Arial"/>
               </a:rPr>
               <a:t>What can this drawing tell us—and what needs checking onsite?</a:t>
+            </a:r>
+          </a:p>
+        </p:txBody>
+      </p:sp>
+      <p:pic>
+        <p:nvPicPr>
+          <p:cNvPr id="25" name=""/>
+          <p:cNvPicPr>
+            <a:picLocks xmlns:a="http://schemas.openxmlformats.org/drawingml/2006/main" noChangeAspect="1"/>
+          </p:cNvPicPr>
+          <p:nvPr/>
+        </p:nvPicPr>
+        <p:blipFill>
+          <a:blip xmlns:r="http://schemas.openxmlformats.org/officeDocument/2006/relationships" xmlns:a="http://schemas.openxmlformats.org/drawingml/2006/main" r:embed="Rfcbb9906d58748d3"/>
+          <a:stretch xmlns:a="http://schemas.openxmlformats.org/drawingml/2006/main"/>
+        </p:blipFill>
+        <p:spPr>
+          <a:xfrm xmlns:a="http://schemas.openxmlformats.org/drawingml/2006/main">
+            <a:off x="5826919" y="4762500"/>
+            <a:ext cx="2014538" cy="1343025"/>
+          </a:xfrm>
+          <a:prstGeom xmlns:a="http://schemas.openxmlformats.org/drawingml/2006/main" prst="rect">
+            <a:avLst/>
+          </a:prstGeom>
+        </p:spPr>
+      </p:pic>
+      <p:sp>
+        <p:nvSpPr>
+          <p:cNvPr id="14" name="">
+            <a:extLst xmlns:a="http://schemas.openxmlformats.org/drawingml/2006/main">
+              <a:ext uri="{FF2B5EF4-FFF2-40B4-BE49-F238E27FC236}">
+                <a16:creationId xmlns:a16="http://schemas.microsoft.com/office/drawing/2014/main" id="{86D6E00B-2FD5-47D8-901A-070F3C77B6C4}"/>
+              </a:ext>
+            </a:extLst>
+          </p:cNvPr>
+          <p:cNvSpPr>
+            <a:spLocks xmlns:a="http://schemas.openxmlformats.org/drawingml/2006/main" noGrp="1"/>
+          </p:cNvSpPr>
+          <p:nvPr/>
+        </p:nvSpPr>
+        <p:spPr>
+          <a:xfrm xmlns:a="http://schemas.openxmlformats.org/drawingml/2006/main">
+            <a:off x="5810250" y="6115050"/>
+            <a:ext cx="2286000" cy="171450"/>
+          </a:xfrm>
+          <a:prstGeom xmlns:a="http://schemas.openxmlformats.org/drawingml/2006/main" prst="rect">
+            <a:avLst/>
+          </a:prstGeom>
+          <a:noFill xmlns:a="http://schemas.openxmlformats.org/drawingml/2006/main"/>
+          <a:ln xmlns:a="http://schemas.openxmlformats.org/drawingml/2006/main" w="0">
+            <a:noFill/>
+          </a:ln>
+        </p:spPr>
+        <p:txBody>
+          <a:bodyPr xmlns:a="http://schemas.openxmlformats.org/drawingml/2006/main">
+            <a:noAutofit/>
+          </a:bodyPr>
+          <a:lstStyle xmlns:a="http://schemas.openxmlformats.org/drawingml/2006/main"/>
+          <a:p xmlns:a="http://schemas.openxmlformats.org/drawingml/2006/main">
+            <a:pPr>
+              <a:defRPr sz="900">
+                <a:solidFill>
+                  <a:srgbClr val="526571"/>
+                </a:solidFill>
+                <a:latin typeface="Arial"/>
+                <a:ea typeface="Arial"/>
+                <a:cs typeface="Arial"/>
+              </a:defRPr>
+            </a:pPr>
+            <a:r>
+              <a:rPr sz="900">
+                <a:solidFill>
+                  <a:srgbClr val="526571"/>
+                </a:solidFill>
+                <a:latin typeface="Arial"/>
+                <a:ea typeface="Arial"/>
+                <a:cs typeface="Arial"/>
+              </a:rPr>
+              <a:t>AI-generated concept image</a:t>
             </a:r>
           </a:p>
         </p:txBody>
@@ -4259,6 +4692,7 @@
           <a:lstStyle xmlns:a="http://schemas.openxmlformats.org/drawingml/2006/main"/>
           <a:p xmlns:a="http://schemas.openxmlformats.org/drawingml/2006/main">
             <a:pPr>
+              <a:buNone/>
               <a:defRPr sz="1200" b="1">
                 <a:solidFill>
                   <a:srgbClr val="2F6079"/>
@@ -4316,6 +4750,7 @@
           <a:lstStyle xmlns:a="http://schemas.openxmlformats.org/drawingml/2006/main"/>
           <a:p xmlns:a="http://schemas.openxmlformats.org/drawingml/2006/main">
             <a:pPr>
+              <a:buNone/>
               <a:defRPr sz="1050" b="0">
                 <a:solidFill>
                   <a:srgbClr val="526571"/>
@@ -4373,6 +4808,7 @@
           <a:lstStyle xmlns:a="http://schemas.openxmlformats.org/drawingml/2006/main"/>
           <a:p xmlns:a="http://schemas.openxmlformats.org/drawingml/2006/main">
             <a:pPr>
+              <a:buNone/>
               <a:defRPr sz="1125" b="1">
                 <a:solidFill>
                   <a:srgbClr val="2F6079"/>
@@ -4430,6 +4866,7 @@
           <a:lstStyle xmlns:a="http://schemas.openxmlformats.org/drawingml/2006/main"/>
           <a:p xmlns:a="http://schemas.openxmlformats.org/drawingml/2006/main">
             <a:pPr>
+              <a:buNone/>
               <a:defRPr sz="2850" b="1">
                 <a:solidFill>
                   <a:srgbClr val="18303F"/>
@@ -4487,6 +4924,7 @@
           <a:lstStyle xmlns:a="http://schemas.openxmlformats.org/drawingml/2006/main"/>
           <a:p xmlns:a="http://schemas.openxmlformats.org/drawingml/2006/main">
             <a:pPr>
+              <a:buNone/>
               <a:defRPr sz="1875" b="0">
                 <a:solidFill>
                   <a:srgbClr val="18303F"/>
@@ -4515,6 +4953,7 @@
           </a:p>
           <a:p xmlns:a="http://schemas.openxmlformats.org/drawingml/2006/main">
             <a:pPr>
+              <a:buNone/>
               <a:defRPr sz="1875" b="0">
                 <a:solidFill>
                   <a:srgbClr val="18303F"/>
@@ -4554,8 +4993,8 @@
         </p:nvSpPr>
         <p:spPr>
           <a:xfrm xmlns:a="http://schemas.openxmlformats.org/drawingml/2006/main">
-            <a:off x="5810250" y="1962150"/>
-            <a:ext cx="5857875" cy="3238500"/>
+            <a:off x="5810250" y="1714500"/>
+            <a:ext cx="5857875" cy="2876550"/>
           </a:xfrm>
           <a:prstGeom xmlns:a="http://schemas.openxmlformats.org/drawingml/2006/main" prst="rect">
             <a:avLst/>
@@ -4570,20 +5009,21 @@
       </p:sp>
       <p:pic>
         <p:nvPicPr>
-          <p:cNvPr id="18" name=""/>
+          <p:cNvPr id="22" name=""/>
           <p:cNvPicPr>
             <a:picLocks xmlns:a="http://schemas.openxmlformats.org/drawingml/2006/main" noChangeAspect="1"/>
           </p:cNvPicPr>
           <p:nvPr/>
         </p:nvPicPr>
         <p:blipFill>
-          <a:blip xmlns:r="http://schemas.openxmlformats.org/officeDocument/2006/relationships" xmlns:a="http://schemas.openxmlformats.org/drawingml/2006/main" r:embed="R48683bee0ff041c4"/>
+          <a:blip xmlns:r="http://schemas.openxmlformats.org/officeDocument/2006/relationships" xmlns:a="http://schemas.openxmlformats.org/drawingml/2006/main" r:embed="Rf6780c4e749247d6"/>
+          <a:srcRect xmlns:a="http://schemas.openxmlformats.org/drawingml/2006/main" l="0" t="0" r="0" b="0"/>
           <a:stretch xmlns:a="http://schemas.openxmlformats.org/drawingml/2006/main"/>
         </p:blipFill>
         <p:spPr>
           <a:xfrm xmlns:a="http://schemas.openxmlformats.org/drawingml/2006/main">
-            <a:off x="6104712" y="2038350"/>
-            <a:ext cx="5268951" cy="3086100"/>
+            <a:off x="6413697" y="1790700"/>
+            <a:ext cx="4650982" cy="2724150"/>
           </a:xfrm>
           <a:prstGeom xmlns:a="http://schemas.openxmlformats.org/drawingml/2006/main" prst="rect">
             <a:avLst/>
@@ -4606,8 +5046,8 @@
         </p:nvSpPr>
         <p:spPr>
           <a:xfrm xmlns:a="http://schemas.openxmlformats.org/drawingml/2006/main">
-            <a:off x="5838825" y="5324475"/>
-            <a:ext cx="5810250" cy="600075"/>
+            <a:off x="8096250" y="4819650"/>
+            <a:ext cx="3571875" cy="1257300"/>
           </a:xfrm>
           <a:prstGeom xmlns:a="http://schemas.openxmlformats.org/drawingml/2006/main" prst="rect">
             <a:avLst/>
@@ -4624,9 +5064,10 @@
           <a:lstStyle xmlns:a="http://schemas.openxmlformats.org/drawingml/2006/main"/>
           <a:p xmlns:a="http://schemas.openxmlformats.org/drawingml/2006/main">
             <a:pPr>
+              <a:buNone/>
               <a:defRPr sz="1125" b="0">
                 <a:solidFill>
-                  <a:srgbClr val="526571"/>
+                  <a:srgbClr val="18303F"/>
                 </a:solidFill>
                 <a:latin typeface="Arial"/>
                 <a:ea typeface="Arial"/>
@@ -4636,7 +5077,7 @@
             <a:r>
               <a:rPr sz="1125" b="0">
                 <a:solidFill>
-                  <a:srgbClr val="526571"/>
+                  <a:srgbClr val="18303F"/>
                 </a:solidFill>
                 <a:latin typeface="Arial"/>
                 <a:ea typeface="Arial"/>
@@ -4681,6 +5122,7 @@
           <a:lstStyle xmlns:a="http://schemas.openxmlformats.org/drawingml/2006/main"/>
           <a:p xmlns:a="http://schemas.openxmlformats.org/drawingml/2006/main">
             <a:pPr>
+              <a:buNone/>
               <a:defRPr sz="1725" b="1">
                 <a:solidFill>
                   <a:srgbClr val="2F6079"/>
@@ -4700,6 +5142,85 @@
                 <a:cs typeface="Arial"/>
               </a:rPr>
               <a:t>Show where the centre lies, then explain diameter versus radius.</a:t>
+            </a:r>
+          </a:p>
+        </p:txBody>
+      </p:sp>
+      <p:pic>
+        <p:nvPicPr>
+          <p:cNvPr id="25" name=""/>
+          <p:cNvPicPr>
+            <a:picLocks xmlns:a="http://schemas.openxmlformats.org/drawingml/2006/main" noChangeAspect="1"/>
+          </p:cNvPicPr>
+          <p:nvPr/>
+        </p:nvPicPr>
+        <p:blipFill>
+          <a:blip xmlns:r="http://schemas.openxmlformats.org/officeDocument/2006/relationships" xmlns:a="http://schemas.openxmlformats.org/drawingml/2006/main" r:embed="R07f0a1f694c148c9"/>
+          <a:stretch xmlns:a="http://schemas.openxmlformats.org/drawingml/2006/main"/>
+        </p:blipFill>
+        <p:spPr>
+          <a:xfrm xmlns:a="http://schemas.openxmlformats.org/drawingml/2006/main">
+            <a:off x="5826919" y="4762500"/>
+            <a:ext cx="2014538" cy="1343025"/>
+          </a:xfrm>
+          <a:prstGeom xmlns:a="http://schemas.openxmlformats.org/drawingml/2006/main" prst="rect">
+            <a:avLst/>
+          </a:prstGeom>
+        </p:spPr>
+      </p:pic>
+      <p:sp>
+        <p:nvSpPr>
+          <p:cNvPr id="14" name="">
+            <a:extLst xmlns:a="http://schemas.openxmlformats.org/drawingml/2006/main">
+              <a:ext uri="{FF2B5EF4-FFF2-40B4-BE49-F238E27FC236}">
+                <a16:creationId xmlns:a16="http://schemas.microsoft.com/office/drawing/2014/main" id="{A97A742F-F89C-4437-B4DE-476A2FDF76C3}"/>
+              </a:ext>
+            </a:extLst>
+          </p:cNvPr>
+          <p:cNvSpPr>
+            <a:spLocks xmlns:a="http://schemas.openxmlformats.org/drawingml/2006/main" noGrp="1"/>
+          </p:cNvSpPr>
+          <p:nvPr/>
+        </p:nvSpPr>
+        <p:spPr>
+          <a:xfrm xmlns:a="http://schemas.openxmlformats.org/drawingml/2006/main">
+            <a:off x="5810250" y="6115050"/>
+            <a:ext cx="2286000" cy="171450"/>
+          </a:xfrm>
+          <a:prstGeom xmlns:a="http://schemas.openxmlformats.org/drawingml/2006/main" prst="rect">
+            <a:avLst/>
+          </a:prstGeom>
+          <a:noFill xmlns:a="http://schemas.openxmlformats.org/drawingml/2006/main"/>
+          <a:ln xmlns:a="http://schemas.openxmlformats.org/drawingml/2006/main" w="0">
+            <a:noFill/>
+          </a:ln>
+        </p:spPr>
+        <p:txBody>
+          <a:bodyPr xmlns:a="http://schemas.openxmlformats.org/drawingml/2006/main">
+            <a:noAutofit/>
+          </a:bodyPr>
+          <a:lstStyle xmlns:a="http://schemas.openxmlformats.org/drawingml/2006/main"/>
+          <a:p xmlns:a="http://schemas.openxmlformats.org/drawingml/2006/main">
+            <a:pPr>
+              <a:defRPr sz="900">
+                <a:solidFill>
+                  <a:srgbClr val="526571"/>
+                </a:solidFill>
+                <a:latin typeface="Arial"/>
+                <a:ea typeface="Arial"/>
+                <a:cs typeface="Arial"/>
+              </a:defRPr>
+            </a:pPr>
+            <a:r>
+              <a:rPr sz="900">
+                <a:solidFill>
+                  <a:srgbClr val="526571"/>
+                </a:solidFill>
+                <a:latin typeface="Arial"/>
+                <a:ea typeface="Arial"/>
+                <a:cs typeface="Arial"/>
+              </a:rPr>
+              <a:t>AI-generated concept image</a:t>
             </a:r>
           </a:p>
         </p:txBody>
@@ -4797,6 +5318,7 @@
           <a:lstStyle xmlns:a="http://schemas.openxmlformats.org/drawingml/2006/main"/>
           <a:p xmlns:a="http://schemas.openxmlformats.org/drawingml/2006/main">
             <a:pPr>
+              <a:buNone/>
               <a:defRPr sz="1200" b="1">
                 <a:solidFill>
                   <a:srgbClr val="2F6079"/>
@@ -4854,6 +5376,7 @@
           <a:lstStyle xmlns:a="http://schemas.openxmlformats.org/drawingml/2006/main"/>
           <a:p xmlns:a="http://schemas.openxmlformats.org/drawingml/2006/main">
             <a:pPr>
+              <a:buNone/>
               <a:defRPr sz="1050" b="0">
                 <a:solidFill>
                   <a:srgbClr val="526571"/>
@@ -4911,6 +5434,7 @@
           <a:lstStyle xmlns:a="http://schemas.openxmlformats.org/drawingml/2006/main"/>
           <a:p xmlns:a="http://schemas.openxmlformats.org/drawingml/2006/main">
             <a:pPr>
+              <a:buNone/>
               <a:defRPr sz="1125" b="1">
                 <a:solidFill>
                   <a:srgbClr val="2F6079"/>
@@ -4968,6 +5492,7 @@
           <a:lstStyle xmlns:a="http://schemas.openxmlformats.org/drawingml/2006/main"/>
           <a:p xmlns:a="http://schemas.openxmlformats.org/drawingml/2006/main">
             <a:pPr>
+              <a:buNone/>
               <a:defRPr sz="3225" b="1">
                 <a:solidFill>
                   <a:srgbClr val="18303F"/>
@@ -5025,6 +5550,7 @@
           <a:lstStyle xmlns:a="http://schemas.openxmlformats.org/drawingml/2006/main"/>
           <a:p xmlns:a="http://schemas.openxmlformats.org/drawingml/2006/main">
             <a:pPr>
+              <a:buNone/>
               <a:defRPr sz="2400" b="1">
                 <a:solidFill>
                   <a:srgbClr val="2F6079"/>
@@ -5065,7 +5591,7 @@
         <p:spPr>
           <a:xfrm xmlns:a="http://schemas.openxmlformats.org/drawingml/2006/main">
             <a:off x="1352550" y="2124075"/>
-            <a:ext cx="10096500" cy="914400"/>
+            <a:ext cx="5619750" cy="1143000"/>
           </a:xfrm>
           <a:prstGeom xmlns:a="http://schemas.openxmlformats.org/drawingml/2006/main" prst="rect">
             <a:avLst/>
@@ -5082,7 +5608,8 @@
           <a:lstStyle xmlns:a="http://schemas.openxmlformats.org/drawingml/2006/main"/>
           <a:p xmlns:a="http://schemas.openxmlformats.org/drawingml/2006/main">
             <a:pPr>
-              <a:defRPr sz="2100" b="0">
+              <a:buNone/>
+              <a:defRPr sz="2025" b="0">
                 <a:solidFill>
                   <a:srgbClr val="18303F"/>
                 </a:solidFill>
@@ -5092,7 +5619,7 @@
               </a:defRPr>
             </a:pPr>
             <a:r>
-              <a:rPr sz="2100" b="0">
+              <a:rPr sz="2025" b="0">
                 <a:solidFill>
                   <a:srgbClr val="18303F"/>
                 </a:solidFill>
@@ -5139,6 +5666,7 @@
           <a:lstStyle xmlns:a="http://schemas.openxmlformats.org/drawingml/2006/main"/>
           <a:p xmlns:a="http://schemas.openxmlformats.org/drawingml/2006/main">
             <a:pPr>
+              <a:buNone/>
               <a:defRPr sz="2400" b="1">
                 <a:solidFill>
                   <a:srgbClr val="2F6079"/>
@@ -5179,7 +5707,7 @@
         <p:spPr>
           <a:xfrm xmlns:a="http://schemas.openxmlformats.org/drawingml/2006/main">
             <a:off x="1352550" y="3276600"/>
-            <a:ext cx="10096500" cy="914400"/>
+            <a:ext cx="5619750" cy="1143000"/>
           </a:xfrm>
           <a:prstGeom xmlns:a="http://schemas.openxmlformats.org/drawingml/2006/main" prst="rect">
             <a:avLst/>
@@ -5196,7 +5724,8 @@
           <a:lstStyle xmlns:a="http://schemas.openxmlformats.org/drawingml/2006/main"/>
           <a:p xmlns:a="http://schemas.openxmlformats.org/drawingml/2006/main">
             <a:pPr>
-              <a:defRPr sz="2100" b="0">
+              <a:buNone/>
+              <a:defRPr sz="2025" b="0">
                 <a:solidFill>
                   <a:srgbClr val="18303F"/>
                 </a:solidFill>
@@ -5206,7 +5735,7 @@
               </a:defRPr>
             </a:pPr>
             <a:r>
-              <a:rPr sz="2100" b="0">
+              <a:rPr sz="2025" b="0">
                 <a:solidFill>
                   <a:srgbClr val="18303F"/>
                 </a:solidFill>
@@ -5253,6 +5782,7 @@
           <a:lstStyle xmlns:a="http://schemas.openxmlformats.org/drawingml/2006/main"/>
           <a:p xmlns:a="http://schemas.openxmlformats.org/drawingml/2006/main">
             <a:pPr>
+              <a:buNone/>
               <a:defRPr sz="2400" b="1">
                 <a:solidFill>
                   <a:srgbClr val="2F6079"/>
@@ -5293,7 +5823,7 @@
         <p:spPr>
           <a:xfrm xmlns:a="http://schemas.openxmlformats.org/drawingml/2006/main">
             <a:off x="1352550" y="4429125"/>
-            <a:ext cx="10096500" cy="914400"/>
+            <a:ext cx="5619750" cy="1143000"/>
           </a:xfrm>
           <a:prstGeom xmlns:a="http://schemas.openxmlformats.org/drawingml/2006/main" prst="rect">
             <a:avLst/>
@@ -5310,7 +5840,8 @@
           <a:lstStyle xmlns:a="http://schemas.openxmlformats.org/drawingml/2006/main"/>
           <a:p xmlns:a="http://schemas.openxmlformats.org/drawingml/2006/main">
             <a:pPr>
-              <a:defRPr sz="2100" b="0">
+              <a:buNone/>
+              <a:defRPr sz="2025" b="0">
                 <a:solidFill>
                   <a:srgbClr val="18303F"/>
                 </a:solidFill>
@@ -5320,7 +5851,7 @@
               </a:defRPr>
             </a:pPr>
             <a:r>
-              <a:rPr sz="2100" b="0">
+              <a:rPr sz="2025" b="0">
                 <a:solidFill>
                   <a:srgbClr val="18303F"/>
                 </a:solidFill>
@@ -5329,6 +5860,85 @@
                 <a:cs typeface="Arial"/>
               </a:rPr>
               <a:t>Show where the centre lies, then explain diameter versus radius.</a:t>
+            </a:r>
+          </a:p>
+        </p:txBody>
+      </p:sp>
+      <p:pic>
+        <p:nvPicPr>
+          <p:cNvPr id="26" name=""/>
+          <p:cNvPicPr>
+            <a:picLocks xmlns:a="http://schemas.openxmlformats.org/drawingml/2006/main" noChangeAspect="1"/>
+          </p:cNvPicPr>
+          <p:nvPr/>
+        </p:nvPicPr>
+        <p:blipFill>
+          <a:blip xmlns:r="http://schemas.openxmlformats.org/officeDocument/2006/relationships" xmlns:a="http://schemas.openxmlformats.org/drawingml/2006/main" r:embed="R7d8bfa0cbdb84113"/>
+          <a:stretch xmlns:a="http://schemas.openxmlformats.org/drawingml/2006/main"/>
+        </p:blipFill>
+        <p:spPr>
+          <a:xfrm xmlns:a="http://schemas.openxmlformats.org/drawingml/2006/main">
+            <a:off x="7620000" y="2484438"/>
+            <a:ext cx="4048125" cy="2698750"/>
+          </a:xfrm>
+          <a:prstGeom xmlns:a="http://schemas.openxmlformats.org/drawingml/2006/main" prst="rect">
+            <a:avLst/>
+          </a:prstGeom>
+        </p:spPr>
+      </p:pic>
+      <p:sp>
+        <p:nvSpPr>
+          <p:cNvPr id="14" name="">
+            <a:extLst xmlns:a="http://schemas.openxmlformats.org/drawingml/2006/main">
+              <a:ext uri="{FF2B5EF4-FFF2-40B4-BE49-F238E27FC236}">
+                <a16:creationId xmlns:a16="http://schemas.microsoft.com/office/drawing/2014/main" id="{B8B81629-AA0E-4109-9B01-B33E3AC2DC2F}"/>
+              </a:ext>
+            </a:extLst>
+          </p:cNvPr>
+          <p:cNvSpPr>
+            <a:spLocks xmlns:a="http://schemas.openxmlformats.org/drawingml/2006/main" noGrp="1"/>
+          </p:cNvSpPr>
+          <p:nvPr/>
+        </p:nvSpPr>
+        <p:spPr>
+          <a:xfrm xmlns:a="http://schemas.openxmlformats.org/drawingml/2006/main">
+            <a:off x="7620000" y="5734050"/>
+            <a:ext cx="4048125" cy="171450"/>
+          </a:xfrm>
+          <a:prstGeom xmlns:a="http://schemas.openxmlformats.org/drawingml/2006/main" prst="rect">
+            <a:avLst/>
+          </a:prstGeom>
+          <a:noFill xmlns:a="http://schemas.openxmlformats.org/drawingml/2006/main"/>
+          <a:ln xmlns:a="http://schemas.openxmlformats.org/drawingml/2006/main" w="0">
+            <a:noFill/>
+          </a:ln>
+        </p:spPr>
+        <p:txBody>
+          <a:bodyPr xmlns:a="http://schemas.openxmlformats.org/drawingml/2006/main">
+            <a:noAutofit/>
+          </a:bodyPr>
+          <a:lstStyle xmlns:a="http://schemas.openxmlformats.org/drawingml/2006/main"/>
+          <a:p xmlns:a="http://schemas.openxmlformats.org/drawingml/2006/main">
+            <a:pPr>
+              <a:defRPr sz="900">
+                <a:solidFill>
+                  <a:srgbClr val="526571"/>
+                </a:solidFill>
+                <a:latin typeface="Arial"/>
+                <a:ea typeface="Arial"/>
+                <a:cs typeface="Arial"/>
+              </a:defRPr>
+            </a:pPr>
+            <a:r>
+              <a:rPr sz="900">
+                <a:solidFill>
+                  <a:srgbClr val="526571"/>
+                </a:solidFill>
+                <a:latin typeface="Arial"/>
+                <a:ea typeface="Arial"/>
+                <a:cs typeface="Arial"/>
+              </a:rPr>
+              <a:t>AI-generated concept image</a:t>
             </a:r>
           </a:p>
         </p:txBody>
@@ -5426,6 +6036,7 @@
           <a:lstStyle xmlns:a="http://schemas.openxmlformats.org/drawingml/2006/main"/>
           <a:p xmlns:a="http://schemas.openxmlformats.org/drawingml/2006/main">
             <a:pPr>
+              <a:buNone/>
               <a:defRPr sz="1200" b="1">
                 <a:solidFill>
                   <a:srgbClr val="2F6079"/>
@@ -5483,6 +6094,7 @@
           <a:lstStyle xmlns:a="http://schemas.openxmlformats.org/drawingml/2006/main"/>
           <a:p xmlns:a="http://schemas.openxmlformats.org/drawingml/2006/main">
             <a:pPr>
+              <a:buNone/>
               <a:defRPr sz="1050" b="0">
                 <a:solidFill>
                   <a:srgbClr val="526571"/>
@@ -5540,6 +6152,7 @@
           <a:lstStyle xmlns:a="http://schemas.openxmlformats.org/drawingml/2006/main"/>
           <a:p xmlns:a="http://schemas.openxmlformats.org/drawingml/2006/main">
             <a:pPr>
+              <a:buNone/>
               <a:defRPr sz="1125" b="1">
                 <a:solidFill>
                   <a:srgbClr val="2F6079"/>
@@ -5597,6 +6210,7 @@
           <a:lstStyle xmlns:a="http://schemas.openxmlformats.org/drawingml/2006/main"/>
           <a:p xmlns:a="http://schemas.openxmlformats.org/drawingml/2006/main">
             <a:pPr>
+              <a:buNone/>
               <a:defRPr sz="2925" b="1">
                 <a:solidFill>
                   <a:srgbClr val="18303F"/>
@@ -5636,8 +6250,8 @@
         </p:nvSpPr>
         <p:spPr>
           <a:xfrm xmlns:a="http://schemas.openxmlformats.org/drawingml/2006/main">
-            <a:off x="514350" y="1962150"/>
-            <a:ext cx="11049000" cy="1181100"/>
+            <a:off x="514350" y="1809750"/>
+            <a:ext cx="11049000" cy="1409700"/>
           </a:xfrm>
           <a:prstGeom xmlns:a="http://schemas.openxmlformats.org/drawingml/2006/main" prst="rect">
             <a:avLst/>
@@ -5654,6 +6268,7 @@
           <a:lstStyle xmlns:a="http://schemas.openxmlformats.org/drawingml/2006/main"/>
           <a:p xmlns:a="http://schemas.openxmlformats.org/drawingml/2006/main">
             <a:pPr>
+              <a:buNone/>
               <a:defRPr sz="2025" b="1">
                 <a:solidFill>
                   <a:srgbClr val="18303F"/>
@@ -5693,8 +6308,8 @@
         </p:nvSpPr>
         <p:spPr>
           <a:xfrm xmlns:a="http://schemas.openxmlformats.org/drawingml/2006/main">
-            <a:off x="514350" y="3476625"/>
-            <a:ext cx="742950" cy="495300"/>
+            <a:off x="514350" y="3333750"/>
+            <a:ext cx="742950" cy="666750"/>
           </a:xfrm>
           <a:prstGeom xmlns:a="http://schemas.openxmlformats.org/drawingml/2006/main" prst="rect">
             <a:avLst/>
@@ -5711,6 +6326,7 @@
           <a:lstStyle xmlns:a="http://schemas.openxmlformats.org/drawingml/2006/main"/>
           <a:p xmlns:a="http://schemas.openxmlformats.org/drawingml/2006/main">
             <a:pPr>
+              <a:buNone/>
               <a:defRPr sz="2250" b="1">
                 <a:solidFill>
                   <a:srgbClr val="2F6079"/>
@@ -5750,8 +6366,8 @@
         </p:nvSpPr>
         <p:spPr>
           <a:xfrm xmlns:a="http://schemas.openxmlformats.org/drawingml/2006/main">
-            <a:off x="1485900" y="3476625"/>
-            <a:ext cx="10001250" cy="714375"/>
+            <a:off x="1485900" y="3333750"/>
+            <a:ext cx="6191250" cy="895350"/>
           </a:xfrm>
           <a:prstGeom xmlns:a="http://schemas.openxmlformats.org/drawingml/2006/main" prst="rect">
             <a:avLst/>
@@ -5768,6 +6384,7 @@
           <a:lstStyle xmlns:a="http://schemas.openxmlformats.org/drawingml/2006/main"/>
           <a:p xmlns:a="http://schemas.openxmlformats.org/drawingml/2006/main">
             <a:pPr>
+              <a:buNone/>
               <a:defRPr sz="1800" b="0">
                 <a:solidFill>
                   <a:srgbClr val="18303F"/>
@@ -5807,8 +6424,8 @@
         </p:nvSpPr>
         <p:spPr>
           <a:xfrm xmlns:a="http://schemas.openxmlformats.org/drawingml/2006/main">
-            <a:off x="514350" y="4295775"/>
-            <a:ext cx="742950" cy="495300"/>
+            <a:off x="514350" y="4305300"/>
+            <a:ext cx="742950" cy="666750"/>
           </a:xfrm>
           <a:prstGeom xmlns:a="http://schemas.openxmlformats.org/drawingml/2006/main" prst="rect">
             <a:avLst/>
@@ -5825,6 +6442,7 @@
           <a:lstStyle xmlns:a="http://schemas.openxmlformats.org/drawingml/2006/main"/>
           <a:p xmlns:a="http://schemas.openxmlformats.org/drawingml/2006/main">
             <a:pPr>
+              <a:buNone/>
               <a:defRPr sz="2250" b="1">
                 <a:solidFill>
                   <a:srgbClr val="2F6079"/>
@@ -5864,8 +6482,8 @@
         </p:nvSpPr>
         <p:spPr>
           <a:xfrm xmlns:a="http://schemas.openxmlformats.org/drawingml/2006/main">
-            <a:off x="1485900" y="4295775"/>
-            <a:ext cx="10001250" cy="714375"/>
+            <a:off x="1485900" y="4305300"/>
+            <a:ext cx="6191250" cy="895350"/>
           </a:xfrm>
           <a:prstGeom xmlns:a="http://schemas.openxmlformats.org/drawingml/2006/main" prst="rect">
             <a:avLst/>
@@ -5882,6 +6500,7 @@
           <a:lstStyle xmlns:a="http://schemas.openxmlformats.org/drawingml/2006/main"/>
           <a:p xmlns:a="http://schemas.openxmlformats.org/drawingml/2006/main">
             <a:pPr>
+              <a:buNone/>
               <a:defRPr sz="1800" b="0">
                 <a:solidFill>
                   <a:srgbClr val="18303F"/>
@@ -5921,8 +6540,8 @@
         </p:nvSpPr>
         <p:spPr>
           <a:xfrm xmlns:a="http://schemas.openxmlformats.org/drawingml/2006/main">
-            <a:off x="514350" y="5114925"/>
-            <a:ext cx="742950" cy="495300"/>
+            <a:off x="514350" y="5276850"/>
+            <a:ext cx="742950" cy="666750"/>
           </a:xfrm>
           <a:prstGeom xmlns:a="http://schemas.openxmlformats.org/drawingml/2006/main" prst="rect">
             <a:avLst/>
@@ -5939,6 +6558,7 @@
           <a:lstStyle xmlns:a="http://schemas.openxmlformats.org/drawingml/2006/main"/>
           <a:p xmlns:a="http://schemas.openxmlformats.org/drawingml/2006/main">
             <a:pPr>
+              <a:buNone/>
               <a:defRPr sz="2250" b="1">
                 <a:solidFill>
                   <a:srgbClr val="2F6079"/>
@@ -5978,8 +6598,8 @@
         </p:nvSpPr>
         <p:spPr>
           <a:xfrm xmlns:a="http://schemas.openxmlformats.org/drawingml/2006/main">
-            <a:off x="1485900" y="5114925"/>
-            <a:ext cx="10001250" cy="714375"/>
+            <a:off x="1485900" y="5276850"/>
+            <a:ext cx="6191250" cy="895350"/>
           </a:xfrm>
           <a:prstGeom xmlns:a="http://schemas.openxmlformats.org/drawingml/2006/main" prst="rect">
             <a:avLst/>
@@ -5996,6 +6616,7 @@
           <a:lstStyle xmlns:a="http://schemas.openxmlformats.org/drawingml/2006/main"/>
           <a:p xmlns:a="http://schemas.openxmlformats.org/drawingml/2006/main">
             <a:pPr>
+              <a:buNone/>
               <a:defRPr sz="1800" b="0">
                 <a:solidFill>
                   <a:srgbClr val="18303F"/>
@@ -6015,6 +6636,85 @@
                 <a:cs typeface="Arial"/>
               </a:rPr>
               <a:t>Distinguish the drawing datum from machine reference and job origin.</a:t>
+            </a:r>
+          </a:p>
+        </p:txBody>
+      </p:sp>
+      <p:pic>
+        <p:nvPicPr>
+          <p:cNvPr id="28" name=""/>
+          <p:cNvPicPr>
+            <a:picLocks xmlns:a="http://schemas.openxmlformats.org/drawingml/2006/main" noChangeAspect="1"/>
+          </p:cNvPicPr>
+          <p:nvPr/>
+        </p:nvPicPr>
+        <p:blipFill>
+          <a:blip xmlns:r="http://schemas.openxmlformats.org/officeDocument/2006/relationships" xmlns:a="http://schemas.openxmlformats.org/drawingml/2006/main" r:embed="Ra770d9ba32fc4b65"/>
+          <a:stretch xmlns:a="http://schemas.openxmlformats.org/drawingml/2006/main"/>
+        </p:blipFill>
+        <p:spPr>
+          <a:xfrm xmlns:a="http://schemas.openxmlformats.org/drawingml/2006/main">
+            <a:off x="7858125" y="3406775"/>
+            <a:ext cx="3810000" cy="2540000"/>
+          </a:xfrm>
+          <a:prstGeom xmlns:a="http://schemas.openxmlformats.org/drawingml/2006/main" prst="rect">
+            <a:avLst/>
+          </a:prstGeom>
+        </p:spPr>
+      </p:pic>
+      <p:sp>
+        <p:nvSpPr>
+          <p:cNvPr id="15" name="">
+            <a:extLst xmlns:a="http://schemas.openxmlformats.org/drawingml/2006/main">
+              <a:ext uri="{FF2B5EF4-FFF2-40B4-BE49-F238E27FC236}">
+                <a16:creationId xmlns:a16="http://schemas.microsoft.com/office/drawing/2014/main" id="{8540E4BD-1E50-4B11-B28E-6306C5FA338B}"/>
+              </a:ext>
+            </a:extLst>
+          </p:cNvPr>
+          <p:cNvSpPr>
+            <a:spLocks xmlns:a="http://schemas.openxmlformats.org/drawingml/2006/main" noGrp="1"/>
+          </p:cNvSpPr>
+          <p:nvPr/>
+        </p:nvSpPr>
+        <p:spPr>
+          <a:xfrm xmlns:a="http://schemas.openxmlformats.org/drawingml/2006/main">
+            <a:off x="7858125" y="6067425"/>
+            <a:ext cx="3810000" cy="171450"/>
+          </a:xfrm>
+          <a:prstGeom xmlns:a="http://schemas.openxmlformats.org/drawingml/2006/main" prst="rect">
+            <a:avLst/>
+          </a:prstGeom>
+          <a:noFill xmlns:a="http://schemas.openxmlformats.org/drawingml/2006/main"/>
+          <a:ln xmlns:a="http://schemas.openxmlformats.org/drawingml/2006/main" w="0">
+            <a:noFill/>
+          </a:ln>
+        </p:spPr>
+        <p:txBody>
+          <a:bodyPr xmlns:a="http://schemas.openxmlformats.org/drawingml/2006/main">
+            <a:noAutofit/>
+          </a:bodyPr>
+          <a:lstStyle xmlns:a="http://schemas.openxmlformats.org/drawingml/2006/main"/>
+          <a:p xmlns:a="http://schemas.openxmlformats.org/drawingml/2006/main">
+            <a:pPr>
+              <a:defRPr sz="900">
+                <a:solidFill>
+                  <a:srgbClr val="526571"/>
+                </a:solidFill>
+                <a:latin typeface="Arial"/>
+                <a:ea typeface="Arial"/>
+                <a:cs typeface="Arial"/>
+              </a:defRPr>
+            </a:pPr>
+            <a:r>
+              <a:rPr sz="900">
+                <a:solidFill>
+                  <a:srgbClr val="526571"/>
+                </a:solidFill>
+                <a:latin typeface="Arial"/>
+                <a:ea typeface="Arial"/>
+                <a:cs typeface="Arial"/>
+              </a:rPr>
+              <a:t>AI-generated concept image</a:t>
             </a:r>
           </a:p>
         </p:txBody>
@@ -6112,6 +6812,7 @@
           <a:lstStyle xmlns:a="http://schemas.openxmlformats.org/drawingml/2006/main"/>
           <a:p xmlns:a="http://schemas.openxmlformats.org/drawingml/2006/main">
             <a:pPr>
+              <a:buNone/>
               <a:defRPr sz="1200" b="1">
                 <a:solidFill>
                   <a:srgbClr val="2F6079"/>
@@ -6169,6 +6870,7 @@
           <a:lstStyle xmlns:a="http://schemas.openxmlformats.org/drawingml/2006/main"/>
           <a:p xmlns:a="http://schemas.openxmlformats.org/drawingml/2006/main">
             <a:pPr>
+              <a:buNone/>
               <a:defRPr sz="1050" b="0">
                 <a:solidFill>
                   <a:srgbClr val="526571"/>
@@ -6226,6 +6928,7 @@
           <a:lstStyle xmlns:a="http://schemas.openxmlformats.org/drawingml/2006/main"/>
           <a:p xmlns:a="http://schemas.openxmlformats.org/drawingml/2006/main">
             <a:pPr>
+              <a:buNone/>
               <a:defRPr sz="1125" b="1">
                 <a:solidFill>
                   <a:srgbClr val="2F6079"/>
@@ -6283,6 +6986,7 @@
           <a:lstStyle xmlns:a="http://schemas.openxmlformats.org/drawingml/2006/main"/>
           <a:p xmlns:a="http://schemas.openxmlformats.org/drawingml/2006/main">
             <a:pPr>
+              <a:buNone/>
               <a:defRPr sz="3225" b="1">
                 <a:solidFill>
                   <a:srgbClr val="18303F"/>
@@ -6323,7 +7027,7 @@
         <p:spPr>
           <a:xfrm xmlns:a="http://schemas.openxmlformats.org/drawingml/2006/main">
             <a:off x="514350" y="2038350"/>
-            <a:ext cx="10953750" cy="2190750"/>
+            <a:ext cx="7524750" cy="2571750"/>
           </a:xfrm>
           <a:prstGeom xmlns:a="http://schemas.openxmlformats.org/drawingml/2006/main" prst="rect">
             <a:avLst/>
@@ -6352,8 +7056,8 @@
         </p:nvSpPr>
         <p:spPr>
           <a:xfrm xmlns:a="http://schemas.openxmlformats.org/drawingml/2006/main">
-            <a:off x="800100" y="2314575"/>
-            <a:ext cx="10334625" cy="1647825"/>
+            <a:off x="800100" y="2247900"/>
+            <a:ext cx="6953250" cy="2238375"/>
           </a:xfrm>
           <a:prstGeom xmlns:a="http://schemas.openxmlformats.org/drawingml/2006/main" prst="rect">
             <a:avLst/>
@@ -6370,7 +7074,8 @@
           <a:lstStyle xmlns:a="http://schemas.openxmlformats.org/drawingml/2006/main"/>
           <a:p xmlns:a="http://schemas.openxmlformats.org/drawingml/2006/main">
             <a:pPr>
-              <a:defRPr sz="2325" b="1">
+              <a:buNone/>
+              <a:defRPr sz="2100" b="1">
                 <a:solidFill>
                   <a:srgbClr val="18303F"/>
                 </a:solidFill>
@@ -6380,7 +7085,7 @@
               </a:defRPr>
             </a:pPr>
             <a:r>
-              <a:rPr sz="2325" b="1">
+              <a:rPr sz="2100" b="1">
                 <a:solidFill>
                   <a:srgbClr val="18303F"/>
                 </a:solidFill>
@@ -6393,7 +7098,8 @@
           </a:p>
           <a:p xmlns:a="http://schemas.openxmlformats.org/drawingml/2006/main">
             <a:pPr>
-              <a:defRPr sz="2325" b="1">
+              <a:buNone/>
+              <a:defRPr sz="2100" b="1">
                 <a:solidFill>
                   <a:srgbClr val="18303F"/>
                 </a:solidFill>
@@ -6403,7 +7109,7 @@
               </a:defRPr>
             </a:pPr>
             <a:r>
-              <a:rPr sz="2325" b="1">
+              <a:rPr sz="2100" b="1">
                 <a:solidFill>
                   <a:srgbClr val="18303F"/>
                 </a:solidFill>
@@ -6416,7 +7122,8 @@
           </a:p>
           <a:p xmlns:a="http://schemas.openxmlformats.org/drawingml/2006/main">
             <a:pPr>
-              <a:defRPr sz="2325" b="1">
+              <a:buNone/>
+              <a:defRPr sz="2100" b="1">
                 <a:solidFill>
                   <a:srgbClr val="18303F"/>
                 </a:solidFill>
@@ -6426,7 +7133,7 @@
               </a:defRPr>
             </a:pPr>
             <a:r>
-              <a:rPr sz="2325" b="1">
+              <a:rPr sz="2100" b="1">
                 <a:solidFill>
                   <a:srgbClr val="18303F"/>
                 </a:solidFill>
@@ -6473,6 +7180,7 @@
           <a:lstStyle xmlns:a="http://schemas.openxmlformats.org/drawingml/2006/main"/>
           <a:p xmlns:a="http://schemas.openxmlformats.org/drawingml/2006/main">
             <a:pPr>
+              <a:buNone/>
               <a:defRPr sz="2175" b="1">
                 <a:solidFill>
                   <a:srgbClr val="2F6079"/>
@@ -6530,6 +7238,7 @@
           <a:lstStyle xmlns:a="http://schemas.openxmlformats.org/drawingml/2006/main"/>
           <a:p xmlns:a="http://schemas.openxmlformats.org/drawingml/2006/main">
             <a:pPr>
+              <a:buNone/>
               <a:defRPr sz="1650" b="0">
                 <a:solidFill>
                   <a:srgbClr val="526571"/>
@@ -6549,6 +7258,85 @@
                 <a:cs typeface="Arial"/>
               </a:rPr>
               <a:t>Browser saving keeps a local copy. Export and verify a backup; follow your teacher’s submission instructions.</a:t>
+            </a:r>
+          </a:p>
+        </p:txBody>
+      </p:sp>
+      <p:pic>
+        <p:nvPicPr>
+          <p:cNvPr id="22" name=""/>
+          <p:cNvPicPr>
+            <a:picLocks xmlns:a="http://schemas.openxmlformats.org/drawingml/2006/main" noChangeAspect="1"/>
+          </p:cNvPicPr>
+          <p:nvPr/>
+        </p:nvPicPr>
+        <p:blipFill>
+          <a:blip xmlns:r="http://schemas.openxmlformats.org/officeDocument/2006/relationships" xmlns:a="http://schemas.openxmlformats.org/drawingml/2006/main" r:embed="R93209d961bcf49f4"/>
+          <a:stretch xmlns:a="http://schemas.openxmlformats.org/drawingml/2006/main"/>
+        </p:blipFill>
+        <p:spPr>
+          <a:xfrm xmlns:a="http://schemas.openxmlformats.org/drawingml/2006/main">
+            <a:off x="8286750" y="2197100"/>
+            <a:ext cx="3381375" cy="2254250"/>
+          </a:xfrm>
+          <a:prstGeom xmlns:a="http://schemas.openxmlformats.org/drawingml/2006/main" prst="rect">
+            <a:avLst/>
+          </a:prstGeom>
+        </p:spPr>
+      </p:pic>
+      <p:sp>
+        <p:nvSpPr>
+          <p:cNvPr id="12" name="">
+            <a:extLst xmlns:a="http://schemas.openxmlformats.org/drawingml/2006/main">
+              <a:ext uri="{FF2B5EF4-FFF2-40B4-BE49-F238E27FC236}">
+                <a16:creationId xmlns:a16="http://schemas.microsoft.com/office/drawing/2014/main" id="{4D680D52-33FE-48D7-81C2-9FAC12DBFC0E}"/>
+              </a:ext>
+            </a:extLst>
+          </p:cNvPr>
+          <p:cNvSpPr>
+            <a:spLocks xmlns:a="http://schemas.openxmlformats.org/drawingml/2006/main" noGrp="1"/>
+          </p:cNvSpPr>
+          <p:nvPr/>
+        </p:nvSpPr>
+        <p:spPr>
+          <a:xfrm xmlns:a="http://schemas.openxmlformats.org/drawingml/2006/main">
+            <a:off x="8286750" y="4543425"/>
+            <a:ext cx="3381375" cy="171450"/>
+          </a:xfrm>
+          <a:prstGeom xmlns:a="http://schemas.openxmlformats.org/drawingml/2006/main" prst="rect">
+            <a:avLst/>
+          </a:prstGeom>
+          <a:noFill xmlns:a="http://schemas.openxmlformats.org/drawingml/2006/main"/>
+          <a:ln xmlns:a="http://schemas.openxmlformats.org/drawingml/2006/main" w="0">
+            <a:noFill/>
+          </a:ln>
+        </p:spPr>
+        <p:txBody>
+          <a:bodyPr xmlns:a="http://schemas.openxmlformats.org/drawingml/2006/main">
+            <a:noAutofit/>
+          </a:bodyPr>
+          <a:lstStyle xmlns:a="http://schemas.openxmlformats.org/drawingml/2006/main"/>
+          <a:p xmlns:a="http://schemas.openxmlformats.org/drawingml/2006/main">
+            <a:pPr>
+              <a:defRPr sz="900">
+                <a:solidFill>
+                  <a:srgbClr val="526571"/>
+                </a:solidFill>
+                <a:latin typeface="Arial"/>
+                <a:ea typeface="Arial"/>
+                <a:cs typeface="Arial"/>
+              </a:defRPr>
+            </a:pPr>
+            <a:r>
+              <a:rPr sz="900">
+                <a:solidFill>
+                  <a:srgbClr val="526571"/>
+                </a:solidFill>
+                <a:latin typeface="Arial"/>
+                <a:ea typeface="Arial"/>
+                <a:cs typeface="Arial"/>
+              </a:rPr>
+              <a:t>AI-generated concept image</a:t>
             </a:r>
           </a:p>
         </p:txBody>

</xml_diff>